<commit_message>
Recommendation Report Topic Presentations
</commit_message>
<xml_diff>
--- a/EGR 3350/Recommendation Report Topic Presentations.pptx
+++ b/EGR 3350/Recommendation Report Topic Presentations.pptx
@@ -120,9 +120,7 @@
 <file path=ppt/revisionInfo.xml><?xml version="1.0" encoding="utf-8"?>
 <p1510:revInfo xmlns:a="http://schemas.openxmlformats.org/drawingml/2006/main" xmlns:r="http://schemas.openxmlformats.org/officeDocument/2006/relationships" xmlns:p1510="http://schemas.microsoft.com/office/powerpoint/2015/10/main">
   <p1510:revLst>
-    <p1510:client id="{654E4E4E-0690-7EA5-52F6-DD90CD0FC8F9}" v="2" dt="2026-02-18T18:04:48.642"/>
-    <p1510:client id="{6FD24483-ADBC-F8D2-8E40-3AA3BCA8CB2C}" v="6" dt="2026-02-18T18:07:27.922"/>
-    <p1510:client id="{F975F386-273E-C572-BDA1-74DEEA9158A7}" v="140" dt="2026-02-18T04:59:22.518"/>
+    <p1510:client id="{5678CCE3-84C4-73C3-6C38-73F5110A8FA9}" v="56" dt="2026-02-24T03:52:13.772"/>
   </p1510:revLst>
 </p1510:revInfo>
 </file>
@@ -258,7 +256,7 @@
           <a:p>
             <a:fld id="{846CE7D5-CF57-46EF-B807-FDD0502418D4}" type="datetimeFigureOut">
               <a:rPr lang="en-US" smtClean="0"/>
-              <a:t>2/18/2026</a:t>
+              <a:t>2/23/2026</a:t>
             </a:fld>
             <a:endParaRPr lang="en-US"/>
           </a:p>
@@ -428,7 +426,7 @@
           <a:p>
             <a:fld id="{846CE7D5-CF57-46EF-B807-FDD0502418D4}" type="datetimeFigureOut">
               <a:rPr lang="en-US" smtClean="0"/>
-              <a:t>2/18/2026</a:t>
+              <a:t>2/23/2026</a:t>
             </a:fld>
             <a:endParaRPr lang="en-US"/>
           </a:p>
@@ -608,7 +606,7 @@
           <a:p>
             <a:fld id="{846CE7D5-CF57-46EF-B807-FDD0502418D4}" type="datetimeFigureOut">
               <a:rPr lang="en-US" smtClean="0"/>
-              <a:t>2/18/2026</a:t>
+              <a:t>2/23/2026</a:t>
             </a:fld>
             <a:endParaRPr lang="en-US"/>
           </a:p>
@@ -778,7 +776,7 @@
           <a:p>
             <a:fld id="{846CE7D5-CF57-46EF-B807-FDD0502418D4}" type="datetimeFigureOut">
               <a:rPr lang="en-US" smtClean="0"/>
-              <a:t>2/18/2026</a:t>
+              <a:t>2/23/2026</a:t>
             </a:fld>
             <a:endParaRPr lang="en-US"/>
           </a:p>
@@ -1024,7 +1022,7 @@
           <a:p>
             <a:fld id="{846CE7D5-CF57-46EF-B807-FDD0502418D4}" type="datetimeFigureOut">
               <a:rPr lang="en-US" smtClean="0"/>
-              <a:t>2/18/2026</a:t>
+              <a:t>2/23/2026</a:t>
             </a:fld>
             <a:endParaRPr lang="en-US"/>
           </a:p>
@@ -1256,7 +1254,7 @@
           <a:p>
             <a:fld id="{846CE7D5-CF57-46EF-B807-FDD0502418D4}" type="datetimeFigureOut">
               <a:rPr lang="en-US" smtClean="0"/>
-              <a:t>2/18/2026</a:t>
+              <a:t>2/23/2026</a:t>
             </a:fld>
             <a:endParaRPr lang="en-US"/>
           </a:p>
@@ -1623,7 +1621,7 @@
           <a:p>
             <a:fld id="{846CE7D5-CF57-46EF-B807-FDD0502418D4}" type="datetimeFigureOut">
               <a:rPr lang="en-US" smtClean="0"/>
-              <a:t>2/18/2026</a:t>
+              <a:t>2/23/2026</a:t>
             </a:fld>
             <a:endParaRPr lang="en-US"/>
           </a:p>
@@ -1741,7 +1739,7 @@
           <a:p>
             <a:fld id="{846CE7D5-CF57-46EF-B807-FDD0502418D4}" type="datetimeFigureOut">
               <a:rPr lang="en-US" smtClean="0"/>
-              <a:t>2/18/2026</a:t>
+              <a:t>2/23/2026</a:t>
             </a:fld>
             <a:endParaRPr lang="en-US"/>
           </a:p>
@@ -1836,7 +1834,7 @@
           <a:p>
             <a:fld id="{846CE7D5-CF57-46EF-B807-FDD0502418D4}" type="datetimeFigureOut">
               <a:rPr lang="en-US" smtClean="0"/>
-              <a:t>2/18/2026</a:t>
+              <a:t>2/23/2026</a:t>
             </a:fld>
             <a:endParaRPr lang="en-US"/>
           </a:p>
@@ -2113,7 +2111,7 @@
           <a:p>
             <a:fld id="{846CE7D5-CF57-46EF-B807-FDD0502418D4}" type="datetimeFigureOut">
               <a:rPr lang="en-US" smtClean="0"/>
-              <a:t>2/18/2026</a:t>
+              <a:t>2/23/2026</a:t>
             </a:fld>
             <a:endParaRPr lang="en-US"/>
           </a:p>
@@ -2370,7 +2368,7 @@
           <a:p>
             <a:fld id="{846CE7D5-CF57-46EF-B807-FDD0502418D4}" type="datetimeFigureOut">
               <a:rPr lang="en-US" smtClean="0"/>
-              <a:t>2/18/2026</a:t>
+              <a:t>2/23/2026</a:t>
             </a:fld>
             <a:endParaRPr lang="en-US"/>
           </a:p>
@@ -2583,7 +2581,7 @@
           <a:p>
             <a:fld id="{846CE7D5-CF57-46EF-B807-FDD0502418D4}" type="datetimeFigureOut">
               <a:rPr lang="en-US" smtClean="0"/>
-              <a:t>2/18/2026</a:t>
+              <a:t>2/23/2026</a:t>
             </a:fld>
             <a:endParaRPr lang="en-US"/>
           </a:p>
@@ -3645,13 +3643,10 @@
           </a:bodyPr>
           <a:lstStyle/>
           <a:p>
-            <a:pPr indent="-228600" algn="l">
-              <a:buFont typeface="Arial" panose="020B0604020202020204" pitchFamily="34" charset="0"/>
-              <a:buChar char="•"/>
-            </a:pPr>
+            <a:pPr algn="l"/>
             <a:r>
               <a:rPr lang="en-US" sz="1700" dirty="0"/>
-              <a:t>Utsav Acharya</a:t>
+              <a:t> Utsav Acharya</a:t>
             </a:r>
             <a:br>
               <a:rPr lang="en-US" sz="1700" dirty="0"/>
@@ -3674,6 +3669,7 @@
               <a:rPr lang="en-US" sz="1700" dirty="0"/>
               <a:t> February 19, 2026</a:t>
             </a:r>
+            <a:endParaRPr lang="en-US"/>
           </a:p>
           <a:p>
             <a:pPr algn="l"/>
@@ -3682,7 +3678,7 @@
                 <a:ea typeface="+mn-lt"/>
                 <a:cs typeface="+mn-lt"/>
               </a:rPr>
-              <a:t>Source: </a:t>
+              <a:t>Figure 1:Source: </a:t>
             </a:r>
             <a:r>
               <a:rPr lang="en-US" sz="1700" dirty="0">
@@ -4123,16 +4119,45 @@
         </p:nvSpPr>
         <p:spPr>
           <a:xfrm>
-            <a:off x="630936" y="2660904"/>
+            <a:off x="787511" y="2660904"/>
             <a:ext cx="4818888" cy="3547872"/>
           </a:xfrm>
         </p:spPr>
         <p:txBody>
           <a:bodyPr vert="horz" lIns="91440" tIns="45720" rIns="91440" bIns="45720" rtlCol="0" anchor="t">
-            <a:normAutofit lnSpcReduction="10000"/>
+            <a:normAutofit fontScale="85000" lnSpcReduction="10000"/>
           </a:bodyPr>
           <a:lstStyle/>
           <a:p>
+            <a:pPr marL="0" indent="0">
+              <a:buNone/>
+            </a:pPr>
+            <a:r>
+              <a:rPr lang="en-US" sz="1900" dirty="0">
+                <a:ea typeface="+mn-lt"/>
+                <a:cs typeface="+mn-lt"/>
+              </a:rPr>
+              <a:t>While working on Wright State University IT department I found many   </a:t>
+            </a:r>
+            <a:r>
+              <a:rPr lang="en-US" sz="1900" dirty="0" err="1">
+                <a:ea typeface="+mn-lt"/>
+                <a:cs typeface="+mn-lt"/>
+              </a:rPr>
+              <a:t>passsword</a:t>
+            </a:r>
+            <a:r>
+              <a:rPr lang="en-US" sz="1900" dirty="0">
+                <a:ea typeface="+mn-lt"/>
+                <a:cs typeface="+mn-lt"/>
+              </a:rPr>
+              <a:t> was found on Dark-web.</a:t>
+            </a:r>
+          </a:p>
+          <a:p>
+            <a:pPr marL="0" indent="0">
+              <a:buNone/>
+            </a:pPr>
             <a:r>
               <a:rPr lang="en-US" sz="1900" dirty="0">
                 <a:ea typeface="+mn-lt"/>
@@ -4140,9 +4165,12 @@
               </a:rPr>
               <a:t>Many students and employees reuse weak passwords across multiple accounts, which increases the risk of security breaches and unauthorized access.</a:t>
             </a:r>
-            <a:endParaRPr lang="en-US" sz="1900" dirty="0"/>
-          </a:p>
-          <a:p>
+            <a:endParaRPr lang="en-US" sz="1900"/>
+          </a:p>
+          <a:p>
+            <a:pPr marL="0" indent="0">
+              <a:buNone/>
+            </a:pPr>
             <a:r>
               <a:rPr lang="en-US" sz="1900" dirty="0">
                 <a:ea typeface="+mn-lt"/>
@@ -4153,6 +4181,9 @@
             <a:endParaRPr lang="en-US" sz="1900" dirty="0"/>
           </a:p>
           <a:p>
+            <a:pPr marL="0" indent="0">
+              <a:buNone/>
+            </a:pPr>
             <a:r>
               <a:rPr lang="en-US" sz="1900" dirty="0">
                 <a:ea typeface="+mn-lt"/>
@@ -4168,7 +4199,7 @@
             </a:pPr>
             <a:r>
               <a:rPr lang="en-US" sz="1900" dirty="0"/>
-              <a:t>Source :</a:t>
+              <a:t>Figure 2:Source :</a:t>
             </a:r>
             <a:r>
               <a:rPr lang="en-US" sz="1900" dirty="0">
@@ -4178,6 +4209,7 @@
               </a:rPr>
               <a:t>hacker/password concept) - Search</a:t>
             </a:r>
+            <a:endParaRPr lang="en-US"/>
           </a:p>
         </p:txBody>
       </p:sp>
@@ -4509,7 +4541,7 @@
         </p:spPr>
         <p:txBody>
           <a:bodyPr vert="horz" lIns="91440" tIns="45720" rIns="91440" bIns="45720" rtlCol="0" anchor="t">
-            <a:normAutofit fontScale="92500" lnSpcReduction="10000"/>
+            <a:normAutofit fontScale="92500" lnSpcReduction="20000"/>
           </a:bodyPr>
           <a:lstStyle/>
           <a:p>
@@ -4521,9 +4553,22 @@
                 <a:ea typeface="+mn-lt"/>
                 <a:cs typeface="+mn-lt"/>
               </a:rPr>
-              <a:t>This topic relates to Computer Science because cybersecurity and authentication systems are critical areas in modern computing.</a:t>
-            </a:r>
-            <a:endParaRPr lang="en-US" sz="1800"/>
+              <a:t>This topic relates to Computer Science because cybersecurity and authentication </a:t>
+            </a:r>
+            <a:r>
+              <a:rPr lang="en-US" sz="1800" dirty="0">
+                <a:ea typeface="+mn-lt"/>
+                <a:cs typeface="+mn-lt"/>
+              </a:rPr>
+              <a:t>systems are critical areas in modern computing.</a:t>
+            </a:r>
+            <a:endParaRPr lang="en-US" sz="1800" dirty="0"/>
+          </a:p>
+          <a:p>
+            <a:pPr>
+              <a:buNone/>
+            </a:pPr>
+            <a:endParaRPr lang="en-US" sz="1900" dirty="0"/>
           </a:p>
           <a:p>
             <a:pPr>
@@ -4594,8 +4639,16 @@
               <a:buNone/>
             </a:pPr>
             <a:r>
+              <a:rPr lang="en-US" sz="1800" dirty="0">
+                <a:latin typeface="Calibri"/>
+                <a:ea typeface="Calibri"/>
+                <a:cs typeface="Calibri"/>
+              </a:rPr>
+              <a:t>Figure 3:Source</a:t>
+            </a:r>
+            <a:r>
               <a:rPr lang="en-US" sz="1800" dirty="0"/>
-              <a:t>Source:</a:t>
+              <a:t>:</a:t>
             </a:r>
             <a:r>
               <a:rPr lang="en-US" sz="1800" dirty="0">
@@ -4605,7 +4658,7 @@
               </a:rPr>
               <a:t>image: cybersecurity shield - Search Images</a:t>
             </a:r>
-            <a:endParaRPr lang="en-US" sz="1800" dirty="0"/>
+            <a:endParaRPr lang="en-US" sz="1800"/>
           </a:p>
           <a:p>
             <a:pPr marL="0" indent="0">
@@ -5131,7 +5184,7 @@
         <p:spPr/>
         <p:txBody>
           <a:bodyPr vert="horz" lIns="91440" tIns="45720" rIns="91440" bIns="45720" rtlCol="0" anchor="t">
-            <a:normAutofit lnSpcReduction="10000"/>
+            <a:normAutofit fontScale="62500" lnSpcReduction="20000"/>
           </a:bodyPr>
           <a:lstStyle/>
           <a:p>
@@ -5156,7 +5209,15 @@
                 <a:ea typeface="+mn-lt"/>
                 <a:cs typeface="+mn-lt"/>
               </a:rPr>
-              <a:t>Cybersecurity research articles</a:t>
+              <a:t>Cybersecurity research articles :</a:t>
+            </a:r>
+            <a:r>
+              <a:rPr lang="en-US" dirty="0">
+                <a:ea typeface="+mn-lt"/>
+                <a:cs typeface="+mn-lt"/>
+                <a:hlinkClick r:id="rId2"/>
+              </a:rPr>
+              <a:t>Journal of Cybersecurity | Oxford Academic</a:t>
             </a:r>
             <a:endParaRPr lang="en-US" dirty="0"/>
           </a:p>
@@ -5169,7 +5230,15 @@
                 <a:ea typeface="+mn-lt"/>
                 <a:cs typeface="+mn-lt"/>
               </a:rPr>
-              <a:t>NIST security guidelines</a:t>
+              <a:t>NIST security guidelines:</a:t>
+            </a:r>
+            <a:r>
+              <a:rPr lang="en-US" dirty="0">
+                <a:ea typeface="+mn-lt"/>
+                <a:cs typeface="+mn-lt"/>
+                <a:hlinkClick r:id="rId3"/>
+              </a:rPr>
+              <a:t>NIST Recommends New Rules for Password Security</a:t>
             </a:r>
             <a:endParaRPr lang="en-US" dirty="0"/>
           </a:p>
@@ -5182,7 +5251,15 @@
                 <a:ea typeface="+mn-lt"/>
                 <a:cs typeface="+mn-lt"/>
               </a:rPr>
-              <a:t>Academic journals</a:t>
+              <a:t>Academic journals:</a:t>
+            </a:r>
+            <a:r>
+              <a:rPr lang="en-US" dirty="0">
+                <a:ea typeface="+mn-lt"/>
+                <a:cs typeface="+mn-lt"/>
+                <a:hlinkClick r:id="rId4"/>
+              </a:rPr>
+              <a:t>An In-Depth Analysis of Password Managers and Two-Factor Authentication Tools | ACM Computing Surveys</a:t>
             </a:r>
             <a:endParaRPr lang="en-US" dirty="0"/>
           </a:p>
@@ -5208,7 +5285,15 @@
                 <a:ea typeface="+mn-lt"/>
                 <a:cs typeface="+mn-lt"/>
               </a:rPr>
-              <a:t>Official product websites</a:t>
+              <a:t>Official product websites :</a:t>
+            </a:r>
+            <a:r>
+              <a:rPr lang="en-US" dirty="0">
+                <a:ea typeface="+mn-lt"/>
+                <a:cs typeface="+mn-lt"/>
+                <a:hlinkClick r:id="rId5"/>
+              </a:rPr>
+              <a:t>#1 Password Manager &amp; Vault App with Single-Sign On &amp; MFA Solutions - LastPass</a:t>
             </a:r>
           </a:p>
           <a:p>
@@ -5220,7 +5305,15 @@
                 <a:ea typeface="+mn-lt"/>
                 <a:cs typeface="+mn-lt"/>
               </a:rPr>
-              <a:t>Security reviews and reports</a:t>
+              <a:t>Security reviews and reports : </a:t>
+            </a:r>
+            <a:r>
+              <a:rPr lang="en-US" dirty="0">
+                <a:ea typeface="+mn-lt"/>
+                <a:cs typeface="+mn-lt"/>
+                <a:hlinkClick r:id="rId6"/>
+              </a:rPr>
+              <a:t>The 2 Best Password Managers of 2026 | Reviews by Wirecutter</a:t>
             </a:r>
             <a:endParaRPr lang="en-US" dirty="0"/>
           </a:p>
@@ -5233,7 +5326,15 @@
                 <a:ea typeface="+mn-lt"/>
                 <a:cs typeface="+mn-lt"/>
               </a:rPr>
-              <a:t>Technology comparison websites</a:t>
+              <a:t>Technology comparison websites:</a:t>
+            </a:r>
+            <a:r>
+              <a:rPr lang="en-US" dirty="0">
+                <a:ea typeface="+mn-lt"/>
+                <a:cs typeface="+mn-lt"/>
+                <a:hlinkClick r:id="rId7"/>
+              </a:rPr>
+              <a:t>The Best Password Managers of 2026: Based On Your Needs | Security.org</a:t>
             </a:r>
             <a:endParaRPr lang="en-US" dirty="0"/>
           </a:p>
@@ -5246,8 +5347,55 @@
                 <a:ea typeface="+mn-lt"/>
                 <a:cs typeface="+mn-lt"/>
               </a:rPr>
-              <a:t>Consumer Reports / TechRadar / PCMag</a:t>
-            </a:r>
+              <a:t>Consumer Reports / TechRadar / PCMag :</a:t>
+            </a:r>
+            <a:r>
+              <a:rPr lang="en-US" dirty="0">
+                <a:ea typeface="+mn-lt"/>
+                <a:cs typeface="+mn-lt"/>
+                <a:hlinkClick r:id="rId8"/>
+              </a:rPr>
+              <a:t>The Best Password Managers We've Tested for 2026 | PCMag</a:t>
+            </a:r>
+          </a:p>
+          <a:p>
+            <a:pPr>
+              <a:buFont typeface="Arial"/>
+            </a:pPr>
+            <a:r>
+              <a:rPr lang="en-US" dirty="0">
+                <a:ea typeface="+mn-lt"/>
+                <a:cs typeface="+mn-lt"/>
+                <a:hlinkClick r:id="rId9"/>
+              </a:rPr>
+              <a:t>Best password manager of 2026: reviewed, rated, and ranked by the experts | TechRadar</a:t>
+            </a:r>
+            <a:endParaRPr lang="en-US" dirty="0">
+              <a:ea typeface="+mn-lt"/>
+              <a:cs typeface="+mn-lt"/>
+            </a:endParaRPr>
+          </a:p>
+          <a:p>
+            <a:pPr>
+              <a:buFont typeface="Arial"/>
+              <a:buChar char="•"/>
+            </a:pPr>
+            <a:r>
+              <a:rPr lang="en-US" dirty="0">
+                <a:ea typeface="+mn-lt"/>
+                <a:cs typeface="+mn-lt"/>
+                <a:hlinkClick r:id="rId10"/>
+              </a:rPr>
+              <a:t>Best Password Manager Reviews – Consumer Reports Reviews – Consumer Reports</a:t>
+            </a:r>
+            <a:endParaRPr lang="en-US" dirty="0"/>
+          </a:p>
+          <a:p>
+            <a:pPr>
+              <a:buFont typeface="Arial"/>
+              <a:buChar char="•"/>
+            </a:pPr>
+            <a:endParaRPr lang="en-US" dirty="0"/>
           </a:p>
           <a:p>
             <a:pPr marL="0" indent="0">

</xml_diff>